<commit_message>
Task 1: watermark opt-in (--draft); footer carries review status from the manifest
The footer now ends 'AI-drafted | reviewed by NAME on DATE' or 'AI-drafted | not reviewed'.
To keep it on one line: fictional note shortened to 'Fictional data', footer box widened to
everything but the brand name's width, and a reviewer name too long for the line falls back
to 'reviewed on DATE' (the name stays in the manifest).

Co-Authored-By: Claude Opus 5 (1M context) <noreply@anthropic.com>
</commit_message>
<xml_diff>
--- a/templates/base.pptx
+++ b/templates/base.pptx
@@ -305,7 +305,7 @@
         <p:spPr>
           <a:xfrm>
             <a:off x="457200" y="6355080"/>
-            <a:ext cx="8686800" cy="365760"/>
+            <a:ext cx="9768840" cy="365760"/>
           </a:xfrm>
         </p:spPr>
         <p:txBody>
@@ -444,7 +444,7 @@
         <p:spPr>
           <a:xfrm>
             <a:off x="457200" y="6355080"/>
-            <a:ext cx="8686800" cy="365760"/>
+            <a:ext cx="9768840" cy="365760"/>
           </a:xfrm>
         </p:spPr>
         <p:txBody>
@@ -498,8 +498,8 @@
         </p:nvSpPr>
         <p:spPr>
           <a:xfrm>
-            <a:off x="9144000" y="6355080"/>
-            <a:ext cx="2590800" cy="365760"/>
+            <a:off x="10226040" y="6355080"/>
+            <a:ext cx="1508760" cy="365760"/>
           </a:xfrm>
           <a:prstGeom prst="rect">
             <a:avLst/>
@@ -507,7 +507,7 @@
           <a:noFill/>
         </p:spPr>
         <p:txBody>
-          <a:bodyPr wrap="none" anchor="ctr">
+          <a:bodyPr wrap="none" anchor="ctr" lIns="0">
             <a:spAutoFit/>
           </a:bodyPr>
           <a:lstStyle/>
@@ -718,7 +718,7 @@
         <p:spPr>
           <a:xfrm>
             <a:off x="457200" y="6355080"/>
-            <a:ext cx="8686800" cy="365760"/>
+            <a:ext cx="9768840" cy="365760"/>
           </a:xfrm>
           <a:prstGeom prst="rect">
             <a:avLst/>

</xml_diff>

<commit_message>
Final Task 3: theme.py holds the only palette, font and type scale; template rebuilt; deck, charts and memo take their colors, Arial and sizes from it; Excel keeps its fills; tests
Co-Authored-By: Claude Opus 5 (1M context) <noreply@anthropic.com>
</commit_message>
<xml_diff>
--- a/templates/base.pptx
+++ b/templates/base.pptx
@@ -111,7 +111,7 @@
     <p:bg>
       <p:bgPr>
         <a:solidFill>
-          <a:srgbClr val="1F2A44"/>
+          <a:srgbClr val="0B2545"/>
         </a:solidFill>
         <a:effectLst/>
       </p:bgPr>
@@ -150,7 +150,7 @@
           <a:bodyPr/>
           <a:lstStyle>
             <a:lvl1pPr>
-              <a:defRPr sz="4000" b="1">
+              <a:defRPr sz="2800" b="1">
                 <a:solidFill>
                   <a:srgbClr val="FFFFFF"/>
                 </a:solidFill>
@@ -278,7 +278,7 @@
             <a:lvl1pPr>
               <a:defRPr sz="2000" b="0">
                 <a:solidFill>
-                  <a:srgbClr val="F2F2F2"/>
+                  <a:srgbClr val="F8FAFC"/>
                 </a:solidFill>
               </a:defRPr>
             </a:lvl1pPr>
@@ -516,7 +516,7 @@
             <a:r>
               <a:rPr sz="1200" b="1">
                 <a:solidFill>
-                  <a:srgbClr val="1F2A44"/>
+                  <a:srgbClr val="0B2545"/>
                 </a:solidFill>
               </a:rPr>
               <a:t>Example Capital</a:t>
@@ -539,7 +539,7 @@
             <a:avLst/>
           </a:prstGeom>
           <a:solidFill>
-            <a:srgbClr val="7F7F7F"/>
+            <a:srgbClr val="E2E8F0"/>
           </a:solidFill>
           <a:ln>
             <a:noFill/>
@@ -582,7 +582,7 @@
             <a:avLst/>
           </a:prstGeom>
           <a:solidFill>
-            <a:srgbClr val="1F2A44"/>
+            <a:srgbClr val="0B2545"/>
           </a:solidFill>
           <a:ln>
             <a:noFill/>
@@ -763,7 +763,7 @@
         <a:buNone/>
         <a:defRPr sz="2800" kern="1200" b="1">
           <a:solidFill>
-            <a:srgbClr val="1F2A44"/>
+            <a:srgbClr val="0B2545"/>
           </a:solidFill>
           <a:latin typeface="+mj-lt"/>
           <a:ea typeface="+mj-ea"/>
@@ -778,9 +778,9 @@
         </a:spcBef>
         <a:buFont typeface="Arial"/>
         <a:buChar char="•"/>
-        <a:defRPr sz="2000" kern="1200" b="0">
-          <a:solidFill>
-            <a:srgbClr val="333333"/>
+        <a:defRPr sz="1500" kern="1200" b="0">
+          <a:solidFill>
+            <a:srgbClr val="334155"/>
           </a:solidFill>
           <a:latin typeface="+mn-lt"/>
           <a:ea typeface="+mn-ea"/>
@@ -793,9 +793,9 @@
         </a:spcBef>
         <a:buFont typeface="Arial"/>
         <a:buChar char="–"/>
-        <a:defRPr sz="1800" kern="1200" b="0">
-          <a:solidFill>
-            <a:srgbClr val="333333"/>
+        <a:defRPr sz="1300" kern="1200" b="0">
+          <a:solidFill>
+            <a:srgbClr val="334155"/>
           </a:solidFill>
           <a:latin typeface="+mn-lt"/>
           <a:ea typeface="+mn-ea"/>
@@ -1018,16 +1018,16 @@
         <a:sysClr val="window" lastClr="FFFFFF"/>
       </a:lt1>
       <a:dk2>
-        <a:srgbClr val="1F2A44"/>
+        <a:srgbClr val="0B2545"/>
       </a:dk2>
       <a:lt2>
-        <a:srgbClr val="F2F2F2"/>
+        <a:srgbClr val="F8FAFC"/>
       </a:lt2>
       <a:accent1>
-        <a:srgbClr val="1F2A44"/>
+        <a:srgbClr val="0B2545"/>
       </a:accent1>
       <a:accent2>
-        <a:srgbClr val="7F7F7F"/>
+        <a:srgbClr val="64748B"/>
       </a:accent2>
       <a:accent3>
         <a:srgbClr val="9BBB59"/>

</xml_diff>

<commit_message>
Task 18: WCAG AA contrast for every text/background pair; passed-flag green darkened, cover footer given its own color
- theme.py: relative_luminance, contrast_ratio, AA thresholds, TEXT_PAIRS and NON_TEXT_PAIRS
- GREEN 1E8449 -> 1A7742: 4.25 : 1 on its fill, now 5.03 : 1
- make_template.py: the cover layout's footer was the master's dark gray on navy (about 1.5 : 1)
- tests/test_contrast.py: the math against hand-worked values, the declared pairs, and pairs read
  from the status colors, the web page's style sheet, Streamlit's theme and four built decks
  (12 of 12 planted bugs caught)
- goldens: the passed-status text color only

Co-Authored-By: Claude Opus 5 (1M context) <noreply@anthropic.com>
</commit_message>
<xml_diff>
--- a/templates/base.pptx
+++ b/templates/base.pptx
@@ -310,7 +310,15 @@
         </p:spPr>
         <p:txBody>
           <a:bodyPr/>
-          <a:lstStyle/>
+          <a:lstStyle>
+            <a:lvl1pPr>
+              <a:defRPr sz="1200" b="0">
+                <a:solidFill>
+                  <a:srgbClr val="F8FAFC"/>
+                </a:solidFill>
+              </a:defRPr>
+            </a:lvl1pPr>
+          </a:lstStyle>
           <a:p>
             <a:endParaRPr lang="en-US"/>
           </a:p>

</xml_diff>